<commit_message>
Update PostgreSQL scripts, tests, presentation, docs, and cleanup
</commit_message>
<xml_diff>
--- a/Superstore  _  Soubi-Charaf.pptx
+++ b/Superstore  _  Soubi-Charaf.pptx
@@ -15,25 +15,26 @@
     <p:sldId id="263" r:id="rId13"/>
     <p:sldId id="264" r:id="rId14"/>
     <p:sldId id="265" r:id="rId15"/>
+    <p:sldId id="266" r:id="rId16"/>
   </p:sldIdLst>
   <p:sldSz cx="18288000" cy="10287000"/>
   <p:notesSz cx="6858000" cy="9144000"/>
   <p:embeddedFontLst>
     <p:embeddedFont>
       <p:font typeface="Aileron Heavy" charset="1" panose="00000A00000000000000"/>
-      <p:regular r:id="rId16"/>
+      <p:regular r:id="rId17"/>
     </p:embeddedFont>
     <p:embeddedFont>
       <p:font typeface="Work Sans Bold" charset="1" panose="00000000000000000000"/>
-      <p:regular r:id="rId17"/>
+      <p:regular r:id="rId18"/>
     </p:embeddedFont>
     <p:embeddedFont>
       <p:font typeface="Aileron Bold" charset="1" panose="00000800000000000000"/>
-      <p:regular r:id="rId18"/>
+      <p:regular r:id="rId19"/>
     </p:embeddedFont>
     <p:embeddedFont>
       <p:font typeface="Work Sans" charset="1" panose="00000000000000000000"/>
-      <p:regular r:id="rId19"/>
+      <p:regular r:id="rId20"/>
     </p:embeddedFont>
   </p:embeddedFontLst>
   <p:defaultTextStyle>
@@ -4388,6 +4389,591 @@
           </a:ln>
         </p:spPr>
       </p:sp>
+      <p:sp>
+        <p:nvSpPr>
+          <p:cNvPr name="Freeform 5" id="5"/>
+          <p:cNvSpPr/>
+          <p:nvPr/>
+        </p:nvSpPr>
+        <p:spPr>
+          <a:xfrm flipH="false" flipV="false" rot="2700000">
+            <a:off x="16714667" y="-579227"/>
+            <a:ext cx="2291553" cy="2703897"/>
+          </a:xfrm>
+          <a:custGeom>
+            <a:avLst/>
+            <a:gdLst/>
+            <a:ahLst/>
+            <a:cxnLst/>
+            <a:rect r="r" b="b" t="t" l="l"/>
+            <a:pathLst>
+              <a:path h="2703897" w="2291553">
+                <a:moveTo>
+                  <a:pt x="0" y="0"/>
+                </a:moveTo>
+                <a:lnTo>
+                  <a:pt x="2291553" y="0"/>
+                </a:lnTo>
+                <a:lnTo>
+                  <a:pt x="2291553" y="2703897"/>
+                </a:lnTo>
+                <a:lnTo>
+                  <a:pt x="0" y="2703897"/>
+                </a:lnTo>
+                <a:lnTo>
+                  <a:pt x="0" y="0"/>
+                </a:lnTo>
+                <a:close/>
+              </a:path>
+            </a:pathLst>
+          </a:custGeom>
+          <a:blipFill>
+            <a:blip r:embed="rId5">
+              <a:alphaModFix amt="39000"/>
+              <a:extLst>
+                <a:ext uri="{96DAC541-7B7A-43D3-8B79-37D633B846F1}">
+                  <asvg:svgBlip xmlns:asvg="http://schemas.microsoft.com/office/drawing/2016/SVG/main" r:embed="rId6"/>
+                </a:ext>
+              </a:extLst>
+            </a:blip>
+            <a:stretch>
+              <a:fillRect l="0" t="0" r="0" b="0"/>
+            </a:stretch>
+          </a:blipFill>
+          <a:ln cap="sq">
+            <a:noFill/>
+            <a:prstDash val="solid"/>
+            <a:miter/>
+          </a:ln>
+        </p:spPr>
+      </p:sp>
+      <p:grpSp>
+        <p:nvGrpSpPr>
+          <p:cNvPr name="Group 6" id="6"/>
+          <p:cNvGrpSpPr/>
+          <p:nvPr/>
+        </p:nvGrpSpPr>
+        <p:grpSpPr>
+          <a:xfrm rot="0">
+            <a:off x="6997247" y="3303491"/>
+            <a:ext cx="10262053" cy="5954809"/>
+            <a:chOff x="0" y="0"/>
+            <a:chExt cx="1432739" cy="831382"/>
+          </a:xfrm>
+        </p:grpSpPr>
+        <p:sp>
+          <p:nvSpPr>
+            <p:cNvPr name="Freeform 7" id="7"/>
+            <p:cNvSpPr/>
+            <p:nvPr/>
+          </p:nvSpPr>
+          <p:spPr>
+            <a:xfrm flipH="false" flipV="false" rot="0">
+              <a:off x="0" y="0"/>
+              <a:ext cx="1432739" cy="831382"/>
+            </a:xfrm>
+            <a:custGeom>
+              <a:avLst/>
+              <a:gdLst/>
+              <a:ahLst/>
+              <a:cxnLst/>
+              <a:rect r="r" b="b" t="t" l="l"/>
+              <a:pathLst>
+                <a:path h="831382" w="1432739">
+                  <a:moveTo>
+                    <a:pt x="15088" y="0"/>
+                  </a:moveTo>
+                  <a:lnTo>
+                    <a:pt x="1417650" y="0"/>
+                  </a:lnTo>
+                  <a:cubicBezTo>
+                    <a:pt x="1425983" y="0"/>
+                    <a:pt x="1432739" y="6755"/>
+                    <a:pt x="1432739" y="15088"/>
+                  </a:cubicBezTo>
+                  <a:lnTo>
+                    <a:pt x="1432739" y="816293"/>
+                  </a:lnTo>
+                  <a:cubicBezTo>
+                    <a:pt x="1432739" y="824627"/>
+                    <a:pt x="1425983" y="831382"/>
+                    <a:pt x="1417650" y="831382"/>
+                  </a:cubicBezTo>
+                  <a:lnTo>
+                    <a:pt x="15088" y="831382"/>
+                  </a:lnTo>
+                  <a:cubicBezTo>
+                    <a:pt x="6755" y="831382"/>
+                    <a:pt x="0" y="824627"/>
+                    <a:pt x="0" y="816293"/>
+                  </a:cubicBezTo>
+                  <a:lnTo>
+                    <a:pt x="0" y="15088"/>
+                  </a:lnTo>
+                  <a:cubicBezTo>
+                    <a:pt x="0" y="6755"/>
+                    <a:pt x="6755" y="0"/>
+                    <a:pt x="15088" y="0"/>
+                  </a:cubicBezTo>
+                  <a:close/>
+                </a:path>
+              </a:pathLst>
+            </a:custGeom>
+            <a:ln w="19050" cap="sq">
+              <a:solidFill>
+                <a:srgbClr val="FFFFFF"/>
+              </a:solidFill>
+              <a:prstDash val="solid"/>
+              <a:miter/>
+            </a:ln>
+          </p:spPr>
+        </p:sp>
+        <p:sp>
+          <p:nvSpPr>
+            <p:cNvPr name="TextBox 8" id="8"/>
+            <p:cNvSpPr txBox="true"/>
+            <p:nvPr/>
+          </p:nvSpPr>
+          <p:spPr>
+            <a:xfrm>
+              <a:off x="0" y="-9525"/>
+              <a:ext cx="1432739" cy="840907"/>
+            </a:xfrm>
+            <a:prstGeom prst="rect">
+              <a:avLst/>
+            </a:prstGeom>
+          </p:spPr>
+          <p:txBody>
+            <a:bodyPr anchor="ctr" rtlCol="false" tIns="50800" lIns="50800" bIns="50800" rIns="50800"/>
+            <a:lstStyle/>
+            <a:p>
+              <a:pPr algn="ctr" marL="0" indent="0" lvl="0">
+                <a:lnSpc>
+                  <a:spcPts val="2880"/>
+                </a:lnSpc>
+                <a:spcBef>
+                  <a:spcPct val="0"/>
+                </a:spcBef>
+              </a:pPr>
+            </a:p>
+          </p:txBody>
+        </p:sp>
+      </p:grpSp>
+      <p:grpSp>
+        <p:nvGrpSpPr>
+          <p:cNvPr name="Group 9" id="9"/>
+          <p:cNvGrpSpPr/>
+          <p:nvPr/>
+        </p:nvGrpSpPr>
+        <p:grpSpPr>
+          <a:xfrm rot="0">
+            <a:off x="1028700" y="710079"/>
+            <a:ext cx="6450258" cy="3657600"/>
+            <a:chOff x="0" y="0"/>
+            <a:chExt cx="8600343" cy="4876800"/>
+          </a:xfrm>
+        </p:grpSpPr>
+        <p:sp>
+          <p:nvSpPr>
+            <p:cNvPr name="Freeform 10" id="10"/>
+            <p:cNvSpPr/>
+            <p:nvPr/>
+          </p:nvSpPr>
+          <p:spPr>
+            <a:xfrm flipH="false" flipV="false" rot="0">
+              <a:off x="6223672" y="1918071"/>
+              <a:ext cx="1977142" cy="1243128"/>
+            </a:xfrm>
+            <a:custGeom>
+              <a:avLst/>
+              <a:gdLst/>
+              <a:ahLst/>
+              <a:cxnLst/>
+              <a:rect r="r" b="b" t="t" l="l"/>
+              <a:pathLst>
+                <a:path h="1243128" w="1977142">
+                  <a:moveTo>
+                    <a:pt x="0" y="0"/>
+                  </a:moveTo>
+                  <a:lnTo>
+                    <a:pt x="1977143" y="0"/>
+                  </a:lnTo>
+                  <a:lnTo>
+                    <a:pt x="1977143" y="1243129"/>
+                  </a:lnTo>
+                  <a:lnTo>
+                    <a:pt x="0" y="1243129"/>
+                  </a:lnTo>
+                  <a:lnTo>
+                    <a:pt x="0" y="0"/>
+                  </a:lnTo>
+                  <a:close/>
+                </a:path>
+              </a:pathLst>
+            </a:custGeom>
+            <a:blipFill>
+              <a:blip r:embed="rId7">
+                <a:extLst>
+                  <a:ext uri="{96DAC541-7B7A-43D3-8B79-37D633B846F1}">
+                    <asvg:svgBlip xmlns:asvg="http://schemas.microsoft.com/office/drawing/2016/SVG/main" r:embed="rId8"/>
+                  </a:ext>
+                </a:extLst>
+              </a:blip>
+              <a:stretch>
+                <a:fillRect l="0" t="0" r="0" b="0"/>
+              </a:stretch>
+            </a:blipFill>
+          </p:spPr>
+        </p:sp>
+        <p:sp>
+          <p:nvSpPr>
+            <p:cNvPr name="TextBox 11" id="11"/>
+            <p:cNvSpPr txBox="true"/>
+            <p:nvPr/>
+          </p:nvSpPr>
+          <p:spPr>
+            <a:xfrm rot="0">
+              <a:off x="0" y="-9525"/>
+              <a:ext cx="8600343" cy="4886325"/>
+            </a:xfrm>
+            <a:prstGeom prst="rect">
+              <a:avLst/>
+            </a:prstGeom>
+          </p:spPr>
+          <p:txBody>
+            <a:bodyPr anchor="t" rtlCol="false" tIns="0" lIns="0" bIns="0" rIns="0">
+              <a:spAutoFit/>
+            </a:bodyPr>
+            <a:lstStyle/>
+            <a:p>
+              <a:pPr algn="l">
+                <a:lnSpc>
+                  <a:spcPts val="9600"/>
+                </a:lnSpc>
+              </a:pPr>
+              <a:r>
+                <a:rPr lang="en-US" sz="8000" b="true">
+                  <a:solidFill>
+                    <a:srgbClr val="FFFFFF"/>
+                  </a:solidFill>
+                  <a:latin typeface="Aileron Bold"/>
+                  <a:ea typeface="Aileron Bold"/>
+                  <a:cs typeface="Aileron Bold"/>
+                  <a:sym typeface="Aileron Bold"/>
+                </a:rPr>
+                <a:t>Technologies Utilisées</a:t>
+              </a:r>
+            </a:p>
+            <a:p>
+              <a:pPr algn="l">
+                <a:lnSpc>
+                  <a:spcPts val="9600"/>
+                </a:lnSpc>
+              </a:pPr>
+            </a:p>
+          </p:txBody>
+        </p:sp>
+      </p:grpSp>
+      <p:sp>
+        <p:nvSpPr>
+          <p:cNvPr name="TextBox 12" id="12"/>
+          <p:cNvSpPr txBox="true"/>
+          <p:nvPr/>
+        </p:nvSpPr>
+        <p:spPr>
+          <a:xfrm rot="0">
+            <a:off x="7284175" y="3842845"/>
+            <a:ext cx="9688198" cy="4780852"/>
+          </a:xfrm>
+          <a:prstGeom prst="rect">
+            <a:avLst/>
+          </a:prstGeom>
+        </p:spPr>
+        <p:txBody>
+          <a:bodyPr anchor="t" rtlCol="false" tIns="0" lIns="0" bIns="0" rIns="0">
+            <a:spAutoFit/>
+          </a:bodyPr>
+          <a:lstStyle/>
+          <a:p>
+            <a:pPr algn="l">
+              <a:lnSpc>
+                <a:spcPts val="6338"/>
+              </a:lnSpc>
+            </a:pPr>
+            <a:r>
+              <a:rPr lang="en-US" sz="4527" u="sng">
+                <a:solidFill>
+                  <a:srgbClr val="FFFFFF"/>
+                </a:solidFill>
+                <a:latin typeface="Work Sans"/>
+                <a:ea typeface="Work Sans"/>
+                <a:cs typeface="Work Sans"/>
+                <a:sym typeface="Work Sans"/>
+              </a:rPr>
+              <a:t>Pandas</a:t>
+            </a:r>
+            <a:r>
+              <a:rPr lang="en-US" sz="4527">
+                <a:solidFill>
+                  <a:srgbClr val="FFFFFF"/>
+                </a:solidFill>
+                <a:latin typeface="Work Sans"/>
+                <a:ea typeface="Work Sans"/>
+                <a:cs typeface="Work Sans"/>
+                <a:sym typeface="Work Sans"/>
+              </a:rPr>
+              <a:t> : Pour la manipulation et le nettoyage des données.</a:t>
+            </a:r>
+          </a:p>
+          <a:p>
+            <a:pPr algn="l">
+              <a:lnSpc>
+                <a:spcPts val="6338"/>
+              </a:lnSpc>
+            </a:pPr>
+            <a:r>
+              <a:rPr lang="en-US" sz="4527" u="sng">
+                <a:solidFill>
+                  <a:srgbClr val="FFFFFF"/>
+                </a:solidFill>
+                <a:latin typeface="Work Sans"/>
+                <a:ea typeface="Work Sans"/>
+                <a:cs typeface="Work Sans"/>
+                <a:sym typeface="Work Sans"/>
+              </a:rPr>
+              <a:t>Matplotlib</a:t>
+            </a:r>
+            <a:r>
+              <a:rPr lang="en-US" sz="4527">
+                <a:solidFill>
+                  <a:srgbClr val="FFFFFF"/>
+                </a:solidFill>
+                <a:latin typeface="Work Sans"/>
+                <a:ea typeface="Work Sans"/>
+                <a:cs typeface="Work Sans"/>
+                <a:sym typeface="Work Sans"/>
+              </a:rPr>
+              <a:t> : Pour la création des graphiques.</a:t>
+            </a:r>
+          </a:p>
+          <a:p>
+            <a:pPr algn="l">
+              <a:lnSpc>
+                <a:spcPts val="6338"/>
+              </a:lnSpc>
+            </a:pPr>
+            <a:r>
+              <a:rPr lang="en-US" sz="4527" u="sng">
+                <a:solidFill>
+                  <a:srgbClr val="FFFFFF"/>
+                </a:solidFill>
+                <a:latin typeface="Work Sans"/>
+                <a:ea typeface="Work Sans"/>
+                <a:cs typeface="Work Sans"/>
+                <a:sym typeface="Work Sans"/>
+              </a:rPr>
+              <a:t>Python-docx </a:t>
+            </a:r>
+            <a:r>
+              <a:rPr lang="en-US" sz="4527">
+                <a:solidFill>
+                  <a:srgbClr val="FFFFFF"/>
+                </a:solidFill>
+                <a:latin typeface="Work Sans"/>
+                <a:ea typeface="Work Sans"/>
+                <a:cs typeface="Work Sans"/>
+                <a:sym typeface="Work Sans"/>
+              </a:rPr>
+              <a:t>: Pour la génération automatisée de documents Word.</a:t>
+            </a:r>
+          </a:p>
+        </p:txBody>
+      </p:sp>
+    </p:spTree>
+  </p:cSld>
+  <p:clrMapOvr>
+    <a:masterClrMapping/>
+  </p:clrMapOvr>
+</p:sld>
+</file>
+
+<file path=ppt/slides/slide11.xml><?xml version="1.0" encoding="utf-8"?>
+<p:sld xmlns:p="http://schemas.openxmlformats.org/presentationml/2006/main" xmlns:a="http://schemas.openxmlformats.org/drawingml/2006/main" xmlns:r="http://schemas.openxmlformats.org/officeDocument/2006/relationships">
+  <p:cSld>
+    <p:spTree>
+      <p:nvGrpSpPr>
+        <p:cNvPr id="1" name=""/>
+        <p:cNvGrpSpPr/>
+        <p:nvPr/>
+      </p:nvGrpSpPr>
+      <p:grpSpPr>
+        <a:xfrm>
+          <a:off x="0" y="0"/>
+          <a:ext cx="0" cy="0"/>
+          <a:chOff x="0" y="0"/>
+          <a:chExt cx="0" cy="0"/>
+        </a:xfrm>
+      </p:grpSpPr>
+      <p:sp>
+        <p:nvSpPr>
+          <p:cNvPr name="Freeform 2" id="2"/>
+          <p:cNvSpPr/>
+          <p:nvPr/>
+        </p:nvSpPr>
+        <p:spPr>
+          <a:xfrm flipH="false" flipV="false" rot="5400000">
+            <a:off x="4000500" y="-4000500"/>
+            <a:ext cx="10287000" cy="18288000"/>
+          </a:xfrm>
+          <a:custGeom>
+            <a:avLst/>
+            <a:gdLst/>
+            <a:ahLst/>
+            <a:cxnLst/>
+            <a:rect r="r" b="b" t="t" l="l"/>
+            <a:pathLst>
+              <a:path h="18288000" w="10287000">
+                <a:moveTo>
+                  <a:pt x="0" y="18288000"/>
+                </a:moveTo>
+                <a:lnTo>
+                  <a:pt x="0" y="0"/>
+                </a:lnTo>
+                <a:lnTo>
+                  <a:pt x="10287000" y="0"/>
+                </a:lnTo>
+                <a:lnTo>
+                  <a:pt x="10287000" y="18288000"/>
+                </a:lnTo>
+                <a:lnTo>
+                  <a:pt x="0" y="18288000"/>
+                </a:lnTo>
+                <a:close/>
+              </a:path>
+            </a:pathLst>
+          </a:custGeom>
+          <a:blipFill>
+            <a:blip r:embed="rId2"/>
+            <a:stretch>
+              <a:fillRect l="-12888" t="0" r="-12888" b="0"/>
+            </a:stretch>
+          </a:blipFill>
+        </p:spPr>
+      </p:sp>
+      <p:sp>
+        <p:nvSpPr>
+          <p:cNvPr name="Freeform 3" id="3"/>
+          <p:cNvSpPr/>
+          <p:nvPr/>
+        </p:nvSpPr>
+        <p:spPr>
+          <a:xfrm flipH="false" flipV="false" rot="0">
+            <a:off x="15923816" y="-2052828"/>
+            <a:ext cx="7315200" cy="4105656"/>
+          </a:xfrm>
+          <a:custGeom>
+            <a:avLst/>
+            <a:gdLst/>
+            <a:ahLst/>
+            <a:cxnLst/>
+            <a:rect r="r" b="b" t="t" l="l"/>
+            <a:pathLst>
+              <a:path h="4105656" w="7315200">
+                <a:moveTo>
+                  <a:pt x="0" y="0"/>
+                </a:moveTo>
+                <a:lnTo>
+                  <a:pt x="7315200" y="0"/>
+                </a:lnTo>
+                <a:lnTo>
+                  <a:pt x="7315200" y="4105656"/>
+                </a:lnTo>
+                <a:lnTo>
+                  <a:pt x="0" y="4105656"/>
+                </a:lnTo>
+                <a:lnTo>
+                  <a:pt x="0" y="0"/>
+                </a:lnTo>
+                <a:close/>
+              </a:path>
+            </a:pathLst>
+          </a:custGeom>
+          <a:blipFill>
+            <a:blip r:embed="rId3">
+              <a:extLst>
+                <a:ext uri="{96DAC541-7B7A-43D3-8B79-37D633B846F1}">
+                  <asvg:svgBlip xmlns:asvg="http://schemas.microsoft.com/office/drawing/2016/SVG/main" r:embed="rId4"/>
+                </a:ext>
+              </a:extLst>
+            </a:blip>
+            <a:stretch>
+              <a:fillRect l="0" t="0" r="0" b="0"/>
+            </a:stretch>
+          </a:blipFill>
+          <a:ln cap="sq">
+            <a:noFill/>
+            <a:prstDash val="solid"/>
+            <a:miter/>
+          </a:ln>
+        </p:spPr>
+      </p:sp>
+      <p:sp>
+        <p:nvSpPr>
+          <p:cNvPr name="Freeform 4" id="4"/>
+          <p:cNvSpPr/>
+          <p:nvPr/>
+        </p:nvSpPr>
+        <p:spPr>
+          <a:xfrm flipH="false" flipV="false" rot="0">
+            <a:off x="-4900970" y="8234172"/>
+            <a:ext cx="7315200" cy="4105656"/>
+          </a:xfrm>
+          <a:custGeom>
+            <a:avLst/>
+            <a:gdLst/>
+            <a:ahLst/>
+            <a:cxnLst/>
+            <a:rect r="r" b="b" t="t" l="l"/>
+            <a:pathLst>
+              <a:path h="4105656" w="7315200">
+                <a:moveTo>
+                  <a:pt x="0" y="0"/>
+                </a:moveTo>
+                <a:lnTo>
+                  <a:pt x="7315200" y="0"/>
+                </a:lnTo>
+                <a:lnTo>
+                  <a:pt x="7315200" y="4105656"/>
+                </a:lnTo>
+                <a:lnTo>
+                  <a:pt x="0" y="4105656"/>
+                </a:lnTo>
+                <a:lnTo>
+                  <a:pt x="0" y="0"/>
+                </a:lnTo>
+                <a:close/>
+              </a:path>
+            </a:pathLst>
+          </a:custGeom>
+          <a:blipFill>
+            <a:blip r:embed="rId3">
+              <a:extLst>
+                <a:ext uri="{96DAC541-7B7A-43D3-8B79-37D633B846F1}">
+                  <asvg:svgBlip xmlns:asvg="http://schemas.microsoft.com/office/drawing/2016/SVG/main" r:embed="rId4"/>
+                </a:ext>
+              </a:extLst>
+            </a:blip>
+            <a:stretch>
+              <a:fillRect l="0" t="0" r="0" b="0"/>
+            </a:stretch>
+          </a:blipFill>
+          <a:ln cap="sq">
+            <a:noFill/>
+            <a:prstDash val="solid"/>
+            <a:miter/>
+          </a:ln>
+        </p:spPr>
+      </p:sp>
       <p:grpSp>
         <p:nvGrpSpPr>
           <p:cNvPr name="Group 5" id="5"/>

</xml_diff>